<commit_message>
feat: add branding, generate architecture doc, update all interview docs
- Add "Wayesu Community Research Organisation Ltd" branding to Android
  DashboardScreen and web App.tsx footer
- Generate HeatShield_Agri_Architecture document (PDF + DOCX) covering
  full platform architecture (Web, Android, USSD, ML pipeline)
- Update Deployment_Readiness_Strategy_Report: XGBoost→Random Forest,
  Android readiness 4.5→6.5/10, Web 7.5→8.5/10, ML now deployed
- Update HeatShield_Agri_Pitch_Deck: XGBoost→Random Forest, full org
  name, Raymond Reuel Wayesu
- Update HeatShield_Agri_Budget: add org name
- Update HeatShield_QA_Professional: XGBoost→Random Forest, org attribution
- Update HeatShield_QA_Talking_Points: XGBoost→Random Forest, org attribution
- Add document generation scripts for future regeneration

https://claude.ai/code/session_01Y9ai8kpHrRM5iqa3hXDN3v
</commit_message>
<xml_diff>
--- a/docs/HeatShield_Agri_Pitch_Deck.pptx
+++ b/docs/HeatShield_Agri_Pitch_Deck.pptx
@@ -1786,6 +1786,10 @@
           </a:solidFill>
           <a:ln/>
         </p:spPr>
+        <p:txBody>
+          <a:bodyPr/>
+          <a:p/>
+        </p:txBody>
       </p:sp>
       <p:sp>
         <p:nvSpPr>
@@ -1808,6 +1812,10 @@
           </a:solidFill>
           <a:ln/>
         </p:spPr>
+        <p:txBody>
+          <a:bodyPr/>
+          <a:p/>
+        </p:txBody>
       </p:sp>
       <p:sp>
         <p:nvSpPr>
@@ -1830,6 +1838,10 @@
           </a:solidFill>
           <a:ln/>
         </p:spPr>
+        <p:txBody>
+          <a:bodyPr/>
+          <a:p/>
+        </p:txBody>
       </p:sp>
       <p:sp>
         <p:nvSpPr>
@@ -1953,6 +1965,10 @@
           </a:solidFill>
           <a:ln/>
         </p:spPr>
+        <p:txBody>
+          <a:bodyPr/>
+          <a:p/>
+        </p:txBody>
       </p:sp>
       <p:sp>
         <p:nvSpPr>
@@ -2258,6 +2274,10 @@
           </a:solidFill>
           <a:ln/>
         </p:spPr>
+        <p:txBody>
+          <a:bodyPr/>
+          <a:p/>
+        </p:txBody>
       </p:sp>
       <p:sp>
         <p:nvSpPr>
@@ -2524,6 +2544,10 @@
           </a:solidFill>
           <a:ln/>
         </p:spPr>
+        <p:txBody>
+          <a:bodyPr/>
+          <a:p/>
+        </p:txBody>
       </p:sp>
       <p:sp>
         <p:nvSpPr>
@@ -2663,6 +2687,10 @@
           </a:solidFill>
           <a:ln/>
         </p:spPr>
+        <p:txBody>
+          <a:bodyPr/>
+          <a:p/>
+        </p:txBody>
       </p:sp>
       <p:sp>
         <p:nvSpPr>
@@ -2802,6 +2830,10 @@
           </a:solidFill>
           <a:ln/>
         </p:spPr>
+        <p:txBody>
+          <a:bodyPr/>
+          <a:p/>
+        </p:txBody>
       </p:sp>
       <p:sp>
         <p:nvSpPr>
@@ -2941,6 +2973,10 @@
           </a:solidFill>
           <a:ln/>
         </p:spPr>
+        <p:txBody>
+          <a:bodyPr/>
+          <a:p/>
+        </p:txBody>
       </p:sp>
       <p:sp>
         <p:nvSpPr>
@@ -3463,6 +3499,10 @@
           </a:solidFill>
           <a:ln/>
         </p:spPr>
+        <p:txBody>
+          <a:bodyPr/>
+          <a:p/>
+        </p:txBody>
       </p:sp>
       <p:sp>
         <p:nvSpPr>
@@ -3485,6 +3525,10 @@
           </a:solidFill>
           <a:ln/>
         </p:spPr>
+        <p:txBody>
+          <a:bodyPr/>
+          <a:p/>
+        </p:txBody>
       </p:sp>
       <p:sp>
         <p:nvSpPr>
@@ -3613,6 +3657,10 @@
             </a:outerShdw>
           </a:effectLst>
         </p:spPr>
+        <p:txBody>
+          <a:bodyPr/>
+          <a:p/>
+        </p:txBody>
       </p:sp>
       <p:sp>
         <p:nvSpPr>
@@ -3647,7 +3695,7 @@
                 <a:ea typeface="Georgia" pitchFamily="34" charset="-122"/>
                 <a:cs typeface="Georgia" pitchFamily="34" charset="-120"/>
               </a:rPr>
-              <a:t>Raymond Wayesu</a:t>
+              <a:t>Raymond Reuel Wayesu</a:t>
             </a:r>
             <a:endParaRPr lang="en-US" sz="1800" dirty="0"/>
           </a:p>
@@ -3725,7 +3773,7 @@
                 <a:ea typeface="Calibri" pitchFamily="34" charset="-122"/>
                 <a:cs typeface="Calibri" pitchFamily="34" charset="-120"/>
               </a:rPr>
-              <a:t>Wayesu Research Ltd  •  Uganda</a:t>
+              <a:t>Wayesu Community Research Organisation Ltd  •  Uganda</a:t>
             </a:r>
             <a:endParaRPr lang="en-US" sz="1200" dirty="0"/>
           </a:p>
@@ -3828,6 +3876,10 @@
             </a:outerShdw>
           </a:effectLst>
         </p:spPr>
+        <p:txBody>
+          <a:bodyPr/>
+          <a:p/>
+        </p:txBody>
       </p:sp>
       <p:sp>
         <p:nvSpPr>
@@ -4012,6 +4064,10 @@
           </a:solidFill>
           <a:ln/>
         </p:spPr>
+        <p:txBody>
+          <a:bodyPr/>
+          <a:p/>
+        </p:txBody>
       </p:sp>
       <p:sp>
         <p:nvSpPr>
@@ -4229,6 +4285,10 @@
             </a:outerShdw>
           </a:effectLst>
         </p:spPr>
+        <p:txBody>
+          <a:bodyPr/>
+          <a:p/>
+        </p:txBody>
       </p:sp>
       <p:sp>
         <p:nvSpPr>
@@ -4288,6 +4348,10 @@
           </a:solidFill>
           <a:ln/>
         </p:spPr>
+        <p:txBody>
+          <a:bodyPr/>
+          <a:p/>
+        </p:txBody>
       </p:sp>
       <p:sp>
         <p:nvSpPr>
@@ -4386,6 +4450,10 @@
           </a:solidFill>
           <a:ln/>
         </p:spPr>
+        <p:txBody>
+          <a:bodyPr/>
+          <a:p/>
+        </p:txBody>
       </p:sp>
       <p:sp>
         <p:nvSpPr>
@@ -4484,6 +4552,10 @@
           </a:solidFill>
           <a:ln/>
         </p:spPr>
+        <p:txBody>
+          <a:bodyPr/>
+          <a:p/>
+        </p:txBody>
       </p:sp>
       <p:sp>
         <p:nvSpPr>
@@ -4582,6 +4654,10 @@
           </a:solidFill>
           <a:ln/>
         </p:spPr>
+        <p:txBody>
+          <a:bodyPr/>
+          <a:p/>
+        </p:txBody>
       </p:sp>
       <p:sp>
         <p:nvSpPr>
@@ -4680,6 +4756,10 @@
           </a:solidFill>
           <a:ln/>
         </p:spPr>
+        <p:txBody>
+          <a:bodyPr/>
+          <a:p/>
+        </p:txBody>
       </p:sp>
       <p:sp>
         <p:nvSpPr>
@@ -4780,6 +4860,10 @@
           </a:solidFill>
           <a:ln/>
         </p:spPr>
+        <p:txBody>
+          <a:bodyPr/>
+          <a:p/>
+        </p:txBody>
       </p:sp>
       <p:sp>
         <p:nvSpPr>
@@ -4973,6 +5057,10 @@
             </a:outerShdw>
           </a:effectLst>
         </p:spPr>
+        <p:txBody>
+          <a:bodyPr/>
+          <a:p/>
+        </p:txBody>
       </p:sp>
       <p:sp>
         <p:nvSpPr>
@@ -4993,6 +5081,10 @@
           </a:solidFill>
           <a:ln/>
         </p:spPr>
+        <p:txBody>
+          <a:bodyPr/>
+          <a:p/>
+        </p:txBody>
       </p:sp>
       <p:sp>
         <p:nvSpPr>
@@ -5188,6 +5280,10 @@
             </a:outerShdw>
           </a:effectLst>
         </p:spPr>
+        <p:txBody>
+          <a:bodyPr/>
+          <a:p/>
+        </p:txBody>
       </p:sp>
       <p:sp>
         <p:nvSpPr>
@@ -5208,6 +5304,10 @@
           </a:solidFill>
           <a:ln/>
         </p:spPr>
+        <p:txBody>
+          <a:bodyPr/>
+          <a:p/>
+        </p:txBody>
       </p:sp>
       <p:sp>
         <p:nvSpPr>
@@ -5403,6 +5503,10 @@
             </a:outerShdw>
           </a:effectLst>
         </p:spPr>
+        <p:txBody>
+          <a:bodyPr/>
+          <a:p/>
+        </p:txBody>
       </p:sp>
       <p:sp>
         <p:nvSpPr>
@@ -5423,6 +5527,10 @@
           </a:solidFill>
           <a:ln/>
         </p:spPr>
+        <p:txBody>
+          <a:bodyPr/>
+          <a:p/>
+        </p:txBody>
       </p:sp>
       <p:sp>
         <p:nvSpPr>
@@ -5611,6 +5719,10 @@
           </a:solidFill>
           <a:ln/>
         </p:spPr>
+        <p:txBody>
+          <a:bodyPr/>
+          <a:p/>
+        </p:txBody>
       </p:sp>
       <p:sp>
         <p:nvSpPr>
@@ -5796,7 +5908,7 @@
                 <a:ea typeface="Calibri" pitchFamily="34" charset="-122"/>
                 <a:cs typeface="Calibri" pitchFamily="34" charset="-120"/>
               </a:rPr>
-              <a:t>(XGBoost + PINN)</a:t>
+              <a:t>(Random Forest + Physics)</a:t>
             </a:r>
             <a:endParaRPr lang="en-US" sz="1000" dirty="0"/>
           </a:p>
@@ -6177,6 +6289,10 @@
           </a:solidFill>
           <a:ln/>
         </p:spPr>
+        <p:txBody>
+          <a:bodyPr/>
+          <a:p/>
+        </p:txBody>
       </p:sp>
       <p:sp>
         <p:nvSpPr>
@@ -6282,6 +6398,10 @@
             </a:outerShdw>
           </a:effectLst>
         </p:spPr>
+        <p:txBody>
+          <a:bodyPr/>
+          <a:p/>
+        </p:txBody>
       </p:sp>
       <p:sp>
         <p:nvSpPr>
@@ -6302,6 +6422,10 @@
           </a:solidFill>
           <a:ln/>
         </p:spPr>
+        <p:txBody>
+          <a:bodyPr/>
+          <a:p/>
+        </p:txBody>
       </p:sp>
       <p:sp>
         <p:nvSpPr>
@@ -6419,6 +6543,10 @@
           </a:solidFill>
           <a:ln/>
         </p:spPr>
+        <p:txBody>
+          <a:bodyPr/>
+          <a:p/>
+        </p:txBody>
       </p:sp>
       <p:sp>
         <p:nvSpPr>
@@ -6524,6 +6652,10 @@
             </a:outerShdw>
           </a:effectLst>
         </p:spPr>
+        <p:txBody>
+          <a:bodyPr/>
+          <a:p/>
+        </p:txBody>
       </p:sp>
       <p:sp>
         <p:nvSpPr>
@@ -6544,6 +6676,10 @@
           </a:solidFill>
           <a:ln/>
         </p:spPr>
+        <p:txBody>
+          <a:bodyPr/>
+          <a:p/>
+        </p:txBody>
       </p:sp>
       <p:sp>
         <p:nvSpPr>
@@ -6661,6 +6797,10 @@
           </a:solidFill>
           <a:ln/>
         </p:spPr>
+        <p:txBody>
+          <a:bodyPr/>
+          <a:p/>
+        </p:txBody>
       </p:sp>
       <p:sp>
         <p:nvSpPr>
@@ -6766,6 +6906,10 @@
             </a:outerShdw>
           </a:effectLst>
         </p:spPr>
+        <p:txBody>
+          <a:bodyPr/>
+          <a:p/>
+        </p:txBody>
       </p:sp>
       <p:sp>
         <p:nvSpPr>
@@ -6786,6 +6930,10 @@
           </a:solidFill>
           <a:ln/>
         </p:spPr>
+        <p:txBody>
+          <a:bodyPr/>
+          <a:p/>
+        </p:txBody>
       </p:sp>
       <p:sp>
         <p:nvSpPr>
@@ -6903,6 +7051,10 @@
           </a:solidFill>
           <a:ln/>
         </p:spPr>
+        <p:txBody>
+          <a:bodyPr/>
+          <a:p/>
+        </p:txBody>
       </p:sp>
       <p:sp>
         <p:nvSpPr>
@@ -7008,6 +7160,10 @@
             </a:outerShdw>
           </a:effectLst>
         </p:spPr>
+        <p:txBody>
+          <a:bodyPr/>
+          <a:p/>
+        </p:txBody>
       </p:sp>
       <p:sp>
         <p:nvSpPr>
@@ -7028,6 +7184,10 @@
           </a:solidFill>
           <a:ln/>
         </p:spPr>
+        <p:txBody>
+          <a:bodyPr/>
+          <a:p/>
+        </p:txBody>
       </p:sp>
       <p:sp>
         <p:nvSpPr>
@@ -7145,6 +7305,10 @@
           </a:solidFill>
           <a:ln/>
         </p:spPr>
+        <p:txBody>
+          <a:bodyPr/>
+          <a:p/>
+        </p:txBody>
       </p:sp>
       <p:sp>
         <p:nvSpPr>
@@ -7321,6 +7485,10 @@
             </a:outerShdw>
           </a:effectLst>
         </p:spPr>
+        <p:txBody>
+          <a:bodyPr/>
+          <a:p/>
+        </p:txBody>
       </p:sp>
       <p:sp>
         <p:nvSpPr>
@@ -7387,6 +7555,10 @@
             <a:prstDash val="solid"/>
           </a:ln>
         </p:spPr>
+        <p:txBody>
+          <a:bodyPr/>
+          <a:p/>
+        </p:txBody>
       </p:sp>
       <p:sp>
         <p:nvSpPr>
@@ -7531,6 +7703,10 @@
             <a:prstDash val="solid"/>
           </a:ln>
         </p:spPr>
+        <p:txBody>
+          <a:bodyPr/>
+          <a:p/>
+        </p:txBody>
       </p:sp>
       <p:sp>
         <p:nvSpPr>
@@ -7604,7 +7780,7 @@
                 <a:ea typeface="Calibri" pitchFamily="34" charset="-122"/>
                 <a:cs typeface="Calibri" pitchFamily="34" charset="-120"/>
               </a:rPr>
-              <a:t>CNN for 5km grid neighborhood</a:t>
+              <a:t>IDW spatial interpolation</a:t>
             </a:r>
             <a:endParaRPr lang="en-US" sz="900" dirty="0"/>
           </a:p>
@@ -7675,6 +7851,10 @@
             <a:prstDash val="solid"/>
           </a:ln>
         </p:spPr>
+        <p:txBody>
+          <a:bodyPr/>
+          <a:p/>
+        </p:txBody>
       </p:sp>
       <p:sp>
         <p:nvSpPr>
@@ -7748,7 +7928,7 @@
                 <a:ea typeface="Calibri" pitchFamily="34" charset="-122"/>
                 <a:cs typeface="Calibri" pitchFamily="34" charset="-120"/>
               </a:rPr>
-              <a:t>LSTM + attention for 72h horizon</a:t>
+              <a:t>Random Forest regression (ONNX)</a:t>
             </a:r>
             <a:endParaRPr lang="en-US" sz="900" dirty="0"/>
           </a:p>
@@ -7819,6 +7999,10 @@
             <a:prstDash val="solid"/>
           </a:ln>
         </p:spPr>
+        <p:txBody>
+          <a:bodyPr/>
+          <a:p/>
+        </p:txBody>
       </p:sp>
       <p:sp>
         <p:nvSpPr>
@@ -7963,6 +8147,10 @@
             <a:prstDash val="solid"/>
           </a:ln>
         </p:spPr>
+        <p:txBody>
+          <a:bodyPr/>
+          <a:p/>
+        </p:txBody>
       </p:sp>
       <p:sp>
         <p:nvSpPr>
@@ -8068,6 +8256,10 @@
             </a:outerShdw>
           </a:effectLst>
         </p:spPr>
+        <p:txBody>
+          <a:bodyPr/>
+          <a:p/>
+        </p:txBody>
       </p:sp>
       <p:sp>
         <p:nvSpPr>
@@ -8240,6 +8432,10 @@
             </a:outerShdw>
           </a:effectLst>
         </p:spPr>
+        <p:txBody>
+          <a:bodyPr/>
+          <a:p/>
+        </p:txBody>
       </p:sp>
       <p:sp>
         <p:nvSpPr>
@@ -8508,7 +8704,7 @@
                 <a:ea typeface="Calibri" pitchFamily="34" charset="-122"/>
                 <a:cs typeface="Calibri" pitchFamily="34" charset="-120"/>
               </a:rPr>
-              <a:t>PyTorch, XGBoost, ONNX</a:t>
+              <a:t>Random Forest, ONNX Runtime</a:t>
             </a:r>
             <a:endParaRPr lang="en-US" sz="1000" dirty="0"/>
           </a:p>
@@ -8689,6 +8885,10 @@
             <a:prstDash val="solid"/>
           </a:ln>
         </p:spPr>
+        <p:txBody>
+          <a:bodyPr/>
+          <a:p/>
+        </p:txBody>
       </p:sp>
       <p:sp>
         <p:nvSpPr>
@@ -8811,6 +9011,10 @@
             <a:prstDash val="solid"/>
           </a:ln>
         </p:spPr>
+        <p:txBody>
+          <a:bodyPr/>
+          <a:p/>
+        </p:txBody>
       </p:sp>
       <p:sp>
         <p:nvSpPr>
@@ -8933,6 +9137,10 @@
             <a:prstDash val="solid"/>
           </a:ln>
         </p:spPr>
+        <p:txBody>
+          <a:bodyPr/>
+          <a:p/>
+        </p:txBody>
       </p:sp>
       <p:sp>
         <p:nvSpPr>
@@ -9195,6 +9403,10 @@
           </a:solidFill>
           <a:ln/>
         </p:spPr>
+        <p:txBody>
+          <a:bodyPr/>
+          <a:p/>
+        </p:txBody>
       </p:sp>
       <p:sp>
         <p:nvSpPr>
@@ -9427,6 +9639,10 @@
             </a:outerShdw>
           </a:effectLst>
         </p:spPr>
+        <p:txBody>
+          <a:bodyPr/>
+          <a:p/>
+        </p:txBody>
       </p:sp>
       <p:sp>
         <p:nvSpPr>
@@ -9447,6 +9663,10 @@
           </a:solidFill>
           <a:ln/>
         </p:spPr>
+        <p:txBody>
+          <a:bodyPr/>
+          <a:p/>
+        </p:txBody>
       </p:sp>
       <p:sp>
         <p:nvSpPr>
@@ -9658,6 +9878,10 @@
             </a:outerShdw>
           </a:effectLst>
         </p:spPr>
+        <p:txBody>
+          <a:bodyPr/>
+          <a:p/>
+        </p:txBody>
       </p:sp>
       <p:sp>
         <p:nvSpPr>
@@ -9678,6 +9902,10 @@
           </a:solidFill>
           <a:ln/>
         </p:spPr>
+        <p:txBody>
+          <a:bodyPr/>
+          <a:p/>
+        </p:txBody>
       </p:sp>
       <p:sp>
         <p:nvSpPr>
@@ -9889,6 +10117,10 @@
             </a:outerShdw>
           </a:effectLst>
         </p:spPr>
+        <p:txBody>
+          <a:bodyPr/>
+          <a:p/>
+        </p:txBody>
       </p:sp>
       <p:sp>
         <p:nvSpPr>
@@ -9909,6 +10141,10 @@
           </a:solidFill>
           <a:ln/>
         </p:spPr>
+        <p:txBody>
+          <a:bodyPr/>
+          <a:p/>
+        </p:txBody>
       </p:sp>
       <p:sp>
         <p:nvSpPr>
@@ -10120,6 +10356,10 @@
             </a:outerShdw>
           </a:effectLst>
         </p:spPr>
+        <p:txBody>
+          <a:bodyPr/>
+          <a:p/>
+        </p:txBody>
       </p:sp>
       <p:sp>
         <p:nvSpPr>
@@ -10140,6 +10380,10 @@
           </a:solidFill>
           <a:ln/>
         </p:spPr>
+        <p:txBody>
+          <a:bodyPr/>
+          <a:p/>
+        </p:txBody>
       </p:sp>
       <p:sp>
         <p:nvSpPr>
@@ -10344,6 +10588,10 @@
           </a:solidFill>
           <a:ln/>
         </p:spPr>
+        <p:txBody>
+          <a:bodyPr/>
+          <a:p/>
+        </p:txBody>
       </p:sp>
       <p:sp>
         <p:nvSpPr>
@@ -10474,6 +10722,10 @@
           </a:solidFill>
           <a:ln/>
         </p:spPr>
+        <p:txBody>
+          <a:bodyPr/>
+          <a:p/>
+        </p:txBody>
       </p:sp>
       <p:sp>
         <p:nvSpPr>
@@ -10496,6 +10748,10 @@
           </a:solidFill>
           <a:ln/>
         </p:spPr>
+        <p:txBody>
+          <a:bodyPr/>
+          <a:p/>
+        </p:txBody>
       </p:sp>
       <p:sp>
         <p:nvSpPr>
@@ -10672,6 +10928,10 @@
           </a:solidFill>
           <a:ln/>
         </p:spPr>
+        <p:txBody>
+          <a:bodyPr/>
+          <a:p/>
+        </p:txBody>
       </p:sp>
       <p:sp>
         <p:nvSpPr>
@@ -10694,6 +10954,10 @@
           </a:solidFill>
           <a:ln/>
         </p:spPr>
+        <p:txBody>
+          <a:bodyPr/>
+          <a:p/>
+        </p:txBody>
       </p:sp>
       <p:sp>
         <p:nvSpPr>
@@ -10870,6 +11134,10 @@
           </a:solidFill>
           <a:ln/>
         </p:spPr>
+        <p:txBody>
+          <a:bodyPr/>
+          <a:p/>
+        </p:txBody>
       </p:sp>
       <p:sp>
         <p:nvSpPr>
@@ -10892,6 +11160,10 @@
           </a:solidFill>
           <a:ln/>
         </p:spPr>
+        <p:txBody>
+          <a:bodyPr/>
+          <a:p/>
+        </p:txBody>
       </p:sp>
       <p:sp>
         <p:nvSpPr>
@@ -11068,6 +11340,10 @@
           </a:solidFill>
           <a:ln/>
         </p:spPr>
+        <p:txBody>
+          <a:bodyPr/>
+          <a:p/>
+        </p:txBody>
       </p:sp>
       <p:sp>
         <p:nvSpPr>
@@ -11090,6 +11366,10 @@
           </a:solidFill>
           <a:ln/>
         </p:spPr>
+        <p:txBody>
+          <a:bodyPr/>
+          <a:p/>
+        </p:txBody>
       </p:sp>
       <p:sp>
         <p:nvSpPr>
@@ -11273,6 +11553,10 @@
             </a:outerShdw>
           </a:effectLst>
         </p:spPr>
+        <p:txBody>
+          <a:bodyPr/>
+          <a:p/>
+        </p:txBody>
       </p:sp>
       <p:sp>
         <p:nvSpPr>
@@ -11517,6 +11801,10 @@
           </a:solidFill>
           <a:ln/>
         </p:spPr>
+        <p:txBody>
+          <a:bodyPr/>
+          <a:p/>
+        </p:txBody>
       </p:sp>
       <p:sp>
         <p:nvSpPr>
@@ -11693,6 +11981,10 @@
             </a:outerShdw>
           </a:effectLst>
         </p:spPr>
+        <p:txBody>
+          <a:bodyPr/>
+          <a:p/>
+        </p:txBody>
       </p:sp>
       <p:sp>
         <p:nvSpPr>
@@ -11713,6 +12005,10 @@
           </a:solidFill>
           <a:ln/>
         </p:spPr>
+        <p:txBody>
+          <a:bodyPr/>
+          <a:p/>
+        </p:txBody>
       </p:sp>
       <p:sp>
         <p:nvSpPr>
@@ -11747,7 +12043,7 @@
                 <a:ea typeface="Georgia" pitchFamily="34" charset="-122"/>
                 <a:cs typeface="Georgia" pitchFamily="34" charset="-120"/>
               </a:rPr>
-              <a:t>Raymond Wayesu</a:t>
+              <a:t>Raymond Reuel Wayesu</a:t>
             </a:r>
             <a:endParaRPr lang="en-US" sz="2000" dirty="0"/>
           </a:p>
@@ -11977,6 +12273,10 @@
           </a:solidFill>
           <a:ln/>
         </p:spPr>
+        <p:txBody>
+          <a:bodyPr/>
+          <a:p/>
+        </p:txBody>
       </p:sp>
       <p:sp>
         <p:nvSpPr>
@@ -12075,6 +12375,10 @@
           </a:solidFill>
           <a:ln/>
         </p:spPr>
+        <p:txBody>
+          <a:bodyPr/>
+          <a:p/>
+        </p:txBody>
       </p:sp>
       <p:sp>
         <p:nvSpPr>
@@ -12173,6 +12477,10 @@
           </a:solidFill>
           <a:ln/>
         </p:spPr>
+        <p:txBody>
+          <a:bodyPr/>
+          <a:p/>
+        </p:txBody>
       </p:sp>
       <p:sp>
         <p:nvSpPr>
@@ -12271,6 +12579,10 @@
           </a:solidFill>
           <a:ln/>
         </p:spPr>
+        <p:txBody>
+          <a:bodyPr/>
+          <a:p/>
+        </p:txBody>
       </p:sp>
       <p:sp>
         <p:nvSpPr>
@@ -12369,6 +12681,10 @@
           </a:solidFill>
           <a:ln/>
         </p:spPr>
+        <p:txBody>
+          <a:bodyPr/>
+          <a:p/>
+        </p:txBody>
       </p:sp>
       <p:sp>
         <p:nvSpPr>
@@ -12467,6 +12783,10 @@
           </a:solidFill>
           <a:ln/>
         </p:spPr>
+        <p:txBody>
+          <a:bodyPr/>
+          <a:p/>
+        </p:txBody>
       </p:sp>
       <p:sp>
         <p:nvSpPr>

</xml_diff>